<commit_message>
w8 efa lec draft
</commit_message>
<xml_diff>
--- a/dapr3_lectures/block2_fa/img_sandbox/dougnuts.pptx
+++ b/dapr3_lectures/block2_fa/img_sandbox/dougnuts.pptx
@@ -261,7 +261,7 @@
           <a:p>
             <a:fld id="{F0028982-11B2-48A6-B27A-92640BCE4ADB}" type="datetimeFigureOut">
               <a:rPr lang="en-GB" smtClean="0"/>
-              <a:t>10/04/2026</a:t>
+              <a:t>03/07/2026</a:t>
             </a:fld>
             <a:endParaRPr lang="en-GB"/>
           </a:p>
@@ -461,7 +461,7 @@
           <a:p>
             <a:fld id="{F0028982-11B2-48A6-B27A-92640BCE4ADB}" type="datetimeFigureOut">
               <a:rPr lang="en-GB" smtClean="0"/>
-              <a:t>10/04/2026</a:t>
+              <a:t>03/07/2026</a:t>
             </a:fld>
             <a:endParaRPr lang="en-GB"/>
           </a:p>
@@ -671,7 +671,7 @@
           <a:p>
             <a:fld id="{F0028982-11B2-48A6-B27A-92640BCE4ADB}" type="datetimeFigureOut">
               <a:rPr lang="en-GB" smtClean="0"/>
-              <a:t>10/04/2026</a:t>
+              <a:t>03/07/2026</a:t>
             </a:fld>
             <a:endParaRPr lang="en-GB"/>
           </a:p>
@@ -871,7 +871,7 @@
           <a:p>
             <a:fld id="{F0028982-11B2-48A6-B27A-92640BCE4ADB}" type="datetimeFigureOut">
               <a:rPr lang="en-GB" smtClean="0"/>
-              <a:t>10/04/2026</a:t>
+              <a:t>03/07/2026</a:t>
             </a:fld>
             <a:endParaRPr lang="en-GB"/>
           </a:p>
@@ -1147,7 +1147,7 @@
           <a:p>
             <a:fld id="{F0028982-11B2-48A6-B27A-92640BCE4ADB}" type="datetimeFigureOut">
               <a:rPr lang="en-GB" smtClean="0"/>
-              <a:t>10/04/2026</a:t>
+              <a:t>03/07/2026</a:t>
             </a:fld>
             <a:endParaRPr lang="en-GB"/>
           </a:p>
@@ -1415,7 +1415,7 @@
           <a:p>
             <a:fld id="{F0028982-11B2-48A6-B27A-92640BCE4ADB}" type="datetimeFigureOut">
               <a:rPr lang="en-GB" smtClean="0"/>
-              <a:t>10/04/2026</a:t>
+              <a:t>03/07/2026</a:t>
             </a:fld>
             <a:endParaRPr lang="en-GB"/>
           </a:p>
@@ -1830,7 +1830,7 @@
           <a:p>
             <a:fld id="{F0028982-11B2-48A6-B27A-92640BCE4ADB}" type="datetimeFigureOut">
               <a:rPr lang="en-GB" smtClean="0"/>
-              <a:t>10/04/2026</a:t>
+              <a:t>03/07/2026</a:t>
             </a:fld>
             <a:endParaRPr lang="en-GB"/>
           </a:p>
@@ -1972,7 +1972,7 @@
           <a:p>
             <a:fld id="{F0028982-11B2-48A6-B27A-92640BCE4ADB}" type="datetimeFigureOut">
               <a:rPr lang="en-GB" smtClean="0"/>
-              <a:t>10/04/2026</a:t>
+              <a:t>03/07/2026</a:t>
             </a:fld>
             <a:endParaRPr lang="en-GB"/>
           </a:p>
@@ -2085,7 +2085,7 @@
           <a:p>
             <a:fld id="{F0028982-11B2-48A6-B27A-92640BCE4ADB}" type="datetimeFigureOut">
               <a:rPr lang="en-GB" smtClean="0"/>
-              <a:t>10/04/2026</a:t>
+              <a:t>03/07/2026</a:t>
             </a:fld>
             <a:endParaRPr lang="en-GB"/>
           </a:p>
@@ -2398,7 +2398,7 @@
           <a:p>
             <a:fld id="{F0028982-11B2-48A6-B27A-92640BCE4ADB}" type="datetimeFigureOut">
               <a:rPr lang="en-GB" smtClean="0"/>
-              <a:t>10/04/2026</a:t>
+              <a:t>03/07/2026</a:t>
             </a:fld>
             <a:endParaRPr lang="en-GB"/>
           </a:p>
@@ -2687,7 +2687,7 @@
           <a:p>
             <a:fld id="{F0028982-11B2-48A6-B27A-92640BCE4ADB}" type="datetimeFigureOut">
               <a:rPr lang="en-GB" smtClean="0"/>
-              <a:t>10/04/2026</a:t>
+              <a:t>03/07/2026</a:t>
             </a:fld>
             <a:endParaRPr lang="en-GB"/>
           </a:p>
@@ -2930,7 +2930,7 @@
           <a:p>
             <a:fld id="{F0028982-11B2-48A6-B27A-92640BCE4ADB}" type="datetimeFigureOut">
               <a:rPr lang="en-GB" smtClean="0"/>
-              <a:t>10/04/2026</a:t>
+              <a:t>03/07/2026</a:t>
             </a:fld>
             <a:endParaRPr lang="en-GB"/>
           </a:p>
@@ -3369,7 +3369,7 @@
         </p:blipFill>
         <p:spPr>
           <a:xfrm>
-            <a:off x="2536879" y="1650577"/>
+            <a:off x="2640391" y="1650577"/>
             <a:ext cx="6660458" cy="2827630"/>
           </a:xfrm>
           <a:prstGeom prst="rect">

</xml_diff>